<commit_message>
Sponsorship packages: page 2 shows only prizes
Co-Authored-By: Claude Sonnet 5.5 <noreply@anthropic.com>
Claude-Session: https://claude.ai/code/session_01Yap9T87JWAqq3mxYKugXQZ
</commit_message>
<xml_diff>
--- a/Logistica_ETH/sponsorship/OILS26_Sponsorship_Packages.pptx
+++ b/Logistica_ETH/sponsorship/OILS26_Sponsorship_Packages.pptx
@@ -3291,28 +3291,54 @@
         </p:nvSpPr>
         <p:spPr>
           <a:xfrm>
-            <a:off x="13716000" y="1883664"/>
-            <a:ext cx="3108960" cy="640080"/>
-          </a:xfrm>
-          <a:prstGeom prst="round2SameRect">
-            <a:avLst/>
-          </a:prstGeom>
-          <a:solidFill>
-            <a:srgbClr val="8CCBF2"/>
-          </a:solidFill>
-          <a:ln/>
-        </p:spPr>
-      </p:sp>
-      <p:sp>
-        <p:nvSpPr>
-          <p:cNvPr id="9" name="Text 5"/>
-          <p:cNvSpPr/>
-          <p:nvPr/>
-        </p:nvSpPr>
-        <p:spPr>
-          <a:xfrm>
-            <a:off x="13716000" y="1883664"/>
-            <a:ext cx="3108960" cy="640080"/>
+            <a:off x="731520" y="3657600"/>
+            <a:ext cx="16093440" cy="2743200"/>
+          </a:xfrm>
+          <a:prstGeom prst="roundRect">
+            <a:avLst>
+              <a:gd name="adj" fmla="val 4667"/>
+            </a:avLst>
+          </a:prstGeom>
+          <a:solidFill>
+            <a:srgbClr val="FFFFFF">
+              <a:alpha val="8000"/>
+            </a:srgbClr>
+          </a:solidFill>
+          <a:ln/>
+        </p:spPr>
+      </p:sp>
+      <p:sp>
+        <p:nvSpPr>
+          <p:cNvPr id="9" name="Shape 5"/>
+          <p:cNvSpPr/>
+          <p:nvPr/>
+        </p:nvSpPr>
+        <p:spPr>
+          <a:xfrm>
+            <a:off x="12435840" y="3657600"/>
+            <a:ext cx="4389120" cy="2743200"/>
+          </a:xfrm>
+          <a:prstGeom prst="rect">
+            <a:avLst/>
+          </a:prstGeom>
+          <a:solidFill>
+            <a:srgbClr val="8CCBF2">
+              <a:alpha val="20000"/>
+            </a:srgbClr>
+          </a:solidFill>
+          <a:ln/>
+        </p:spPr>
+      </p:sp>
+      <p:sp>
+        <p:nvSpPr>
+          <p:cNvPr id="10" name="Text 6"/>
+          <p:cNvSpPr/>
+          <p:nvPr/>
+        </p:nvSpPr>
+        <p:spPr>
+          <a:xfrm>
+            <a:off x="1042416" y="3657600"/>
+            <a:ext cx="11064240" cy="2743200"/>
           </a:xfrm>
           <a:prstGeom prst="rect">
             <a:avLst/>
@@ -3324,113 +3350,28 @@
           <a:bodyPr wrap="square" lIns="0" tIns="0" rIns="0" bIns="0" rtlCol="0" anchor="ctr"/>
           <a:lstStyle/>
           <a:p>
-            <a:pPr algn="ctr" indent="0" marL="0">
-              <a:buNone/>
-            </a:pPr>
-            <a:r>
-              <a:rPr lang="en-US" sz="2736" b="1" dirty="0">
-                <a:solidFill>
-                  <a:srgbClr val="06254E"/>
+            <a:pPr indent="0" marL="0">
+              <a:buNone/>
+            </a:pPr>
+            <a:r>
+              <a:rPr lang="en-US" sz="3888" b="1" dirty="0">
+                <a:solidFill>
+                  <a:srgbClr val="FFFFFF"/>
                 </a:solidFill>
                 <a:latin typeface="Eurostile" pitchFamily="34" charset="0"/>
                 <a:ea typeface="Eurostile" pitchFamily="34" charset="-122"/>
                 <a:cs typeface="Eurostile" pitchFamily="34" charset="-120"/>
               </a:rPr>
-              <a:t>CHF</a:t>
-            </a:r>
-            <a:endParaRPr lang="en-US" sz="2736" dirty="0"/>
-          </a:p>
-        </p:txBody>
-      </p:sp>
-      <p:sp>
-        <p:nvSpPr>
-          <p:cNvPr id="10" name="Shape 6"/>
-          <p:cNvSpPr/>
-          <p:nvPr/>
-        </p:nvSpPr>
-        <p:spPr>
-          <a:xfrm>
-            <a:off x="731520" y="2651760"/>
-            <a:ext cx="16093440" cy="1243584"/>
-          </a:xfrm>
-          <a:prstGeom prst="roundRect">
-            <a:avLst>
-              <a:gd name="adj" fmla="val 10294"/>
-            </a:avLst>
-          </a:prstGeom>
-          <a:solidFill>
-            <a:srgbClr val="FFFFFF">
-              <a:alpha val="8000"/>
-            </a:srgbClr>
-          </a:solidFill>
-          <a:ln/>
-        </p:spPr>
-      </p:sp>
-      <p:sp>
-        <p:nvSpPr>
-          <p:cNvPr id="11" name="Shape 7"/>
-          <p:cNvSpPr/>
-          <p:nvPr/>
-        </p:nvSpPr>
-        <p:spPr>
-          <a:xfrm>
-            <a:off x="13716000" y="2651760"/>
-            <a:ext cx="3108960" cy="1243584"/>
-          </a:xfrm>
-          <a:prstGeom prst="rect">
-            <a:avLst/>
-          </a:prstGeom>
-          <a:solidFill>
-            <a:srgbClr val="8CCBF2">
-              <a:alpha val="20000"/>
-            </a:srgbClr>
-          </a:solidFill>
-          <a:ln/>
-        </p:spPr>
-      </p:sp>
-      <p:sp>
-        <p:nvSpPr>
-          <p:cNvPr id="12" name="Text 8"/>
-          <p:cNvSpPr/>
-          <p:nvPr/>
-        </p:nvSpPr>
-        <p:spPr>
-          <a:xfrm>
-            <a:off x="1042416" y="2651760"/>
-            <a:ext cx="12252960" cy="1243584"/>
-          </a:xfrm>
-          <a:prstGeom prst="rect">
-            <a:avLst/>
-          </a:prstGeom>
-          <a:noFill/>
-          <a:ln/>
-        </p:spPr>
-        <p:txBody>
-          <a:bodyPr wrap="square" lIns="0" tIns="0" rIns="0" bIns="0" rtlCol="0" anchor="ctr"/>
-          <a:lstStyle/>
+              <a:t>Sponsorship for Best Innovation &amp; Science pitch, or Poster winner prizes</a:t>
+            </a:r>
+            <a:endParaRPr lang="en-US" sz="3888" dirty="0"/>
+          </a:p>
           <a:p>
             <a:pPr indent="0" marL="0">
               <a:buNone/>
             </a:pPr>
             <a:r>
-              <a:rPr lang="en-US" sz="2448" b="1" dirty="0">
-                <a:solidFill>
-                  <a:srgbClr val="FFFFFF"/>
-                </a:solidFill>
-                <a:latin typeface="Eurostile" pitchFamily="34" charset="0"/>
-                <a:ea typeface="Eurostile" pitchFamily="34" charset="-122"/>
-                <a:cs typeface="Eurostile" pitchFamily="34" charset="-120"/>
-              </a:rPr>
-              <a:t>Sponsorship of One-to-One Matchmaking Session</a:t>
-            </a:r>
-            <a:endParaRPr lang="en-US" sz="2448" dirty="0"/>
-          </a:p>
-          <a:p>
-            <a:pPr indent="0" marL="0">
-              <a:buNone/>
-            </a:pPr>
-            <a:r>
-              <a:rPr lang="en-US" sz="1800" dirty="0">
+              <a:rPr lang="en-US" sz="2448" dirty="0">
                 <a:solidFill>
                   <a:srgbClr val="C9D6EC"/>
                 </a:solidFill>
@@ -3438,22 +3379,22 @@
                 <a:ea typeface="Arial" pitchFamily="34" charset="-122"/>
                 <a:cs typeface="Arial" pitchFamily="34" charset="-120"/>
               </a:rPr>
-              <a:t>name displayed on agenda</a:t>
-            </a:r>
-            <a:endParaRPr lang="en-US" sz="2448" dirty="0"/>
-          </a:p>
-        </p:txBody>
-      </p:sp>
-      <p:sp>
-        <p:nvSpPr>
-          <p:cNvPr id="13" name="Text 9"/>
-          <p:cNvSpPr/>
-          <p:nvPr/>
-        </p:nvSpPr>
-        <p:spPr>
-          <a:xfrm>
-            <a:off x="13716000" y="2651760"/>
-            <a:ext cx="3108960" cy="1243584"/>
+              <a:t>Cash prize or giveaway (e.g. iPad, camera, gift certificate, etc.)</a:t>
+            </a:r>
+            <a:endParaRPr lang="en-US" sz="3888" dirty="0"/>
+          </a:p>
+        </p:txBody>
+      </p:sp>
+      <p:sp>
+        <p:nvSpPr>
+          <p:cNvPr id="11" name="Text 7"/>
+          <p:cNvSpPr/>
+          <p:nvPr/>
+        </p:nvSpPr>
+        <p:spPr>
+          <a:xfrm>
+            <a:off x="12435840" y="3657600"/>
+            <a:ext cx="4389120" cy="2743200"/>
           </a:xfrm>
           <a:prstGeom prst="rect">
             <a:avLst/>
@@ -3469,581 +3410,17 @@
               <a:buNone/>
             </a:pPr>
             <a:r>
-              <a:rPr lang="en-US" sz="4608" b="1" dirty="0">
+              <a:rPr lang="en-US" sz="3168" b="1" dirty="0">
                 <a:solidFill>
                   <a:srgbClr val="8CCBF2"/>
-                </a:solidFill>
-                <a:latin typeface="Eurostile" pitchFamily="34" charset="0"/>
-                <a:ea typeface="Eurostile" pitchFamily="34" charset="-122"/>
-                <a:cs typeface="Eurostile" pitchFamily="34" charset="-120"/>
-              </a:rPr>
-              <a:t>350</a:t>
-            </a:r>
-            <a:endParaRPr lang="en-US" sz="4608" dirty="0"/>
-          </a:p>
-        </p:txBody>
-      </p:sp>
-      <p:sp>
-        <p:nvSpPr>
-          <p:cNvPr id="14" name="Shape 10"/>
-          <p:cNvSpPr/>
-          <p:nvPr/>
-        </p:nvSpPr>
-        <p:spPr>
-          <a:xfrm>
-            <a:off x="731520" y="4005072"/>
-            <a:ext cx="16093440" cy="1243584"/>
-          </a:xfrm>
-          <a:prstGeom prst="roundRect">
-            <a:avLst>
-              <a:gd name="adj" fmla="val 10294"/>
-            </a:avLst>
-          </a:prstGeom>
-          <a:solidFill>
-            <a:srgbClr val="FFFFFF">
-              <a:alpha val="8000"/>
-            </a:srgbClr>
-          </a:solidFill>
-          <a:ln/>
-        </p:spPr>
-      </p:sp>
-      <p:sp>
-        <p:nvSpPr>
-          <p:cNvPr id="15" name="Shape 11"/>
-          <p:cNvSpPr/>
-          <p:nvPr/>
-        </p:nvSpPr>
-        <p:spPr>
-          <a:xfrm>
-            <a:off x="13716000" y="4005072"/>
-            <a:ext cx="3108960" cy="1243584"/>
-          </a:xfrm>
-          <a:prstGeom prst="rect">
-            <a:avLst/>
-          </a:prstGeom>
-          <a:solidFill>
-            <a:srgbClr val="8CCBF2">
-              <a:alpha val="20000"/>
-            </a:srgbClr>
-          </a:solidFill>
-          <a:ln/>
-        </p:spPr>
-      </p:sp>
-      <p:sp>
-        <p:nvSpPr>
-          <p:cNvPr id="16" name="Text 12"/>
-          <p:cNvSpPr/>
-          <p:nvPr/>
-        </p:nvSpPr>
-        <p:spPr>
-          <a:xfrm>
-            <a:off x="1042416" y="4005072"/>
-            <a:ext cx="12252960" cy="1243584"/>
-          </a:xfrm>
-          <a:prstGeom prst="rect">
-            <a:avLst/>
-          </a:prstGeom>
-          <a:noFill/>
-          <a:ln/>
-        </p:spPr>
-        <p:txBody>
-          <a:bodyPr wrap="square" lIns="0" tIns="0" rIns="0" bIns="0" rtlCol="0" anchor="ctr"/>
-          <a:lstStyle/>
-          <a:p>
-            <a:pPr indent="0" marL="0">
-              <a:buNone/>
-            </a:pPr>
-            <a:r>
-              <a:rPr lang="en-US" sz="2448" b="1" dirty="0">
-                <a:solidFill>
-                  <a:srgbClr val="FFFFFF"/>
-                </a:solidFill>
-                <a:latin typeface="Eurostile" pitchFamily="34" charset="0"/>
-                <a:ea typeface="Eurostile" pitchFamily="34" charset="-122"/>
-                <a:cs typeface="Eurostile" pitchFamily="34" charset="-120"/>
-              </a:rPr>
-              <a:t>Sponsorship of a conference room</a:t>
-            </a:r>
-            <a:endParaRPr lang="en-US" sz="2448" dirty="0"/>
-          </a:p>
-          <a:p>
-            <a:pPr indent="0" marL="0">
-              <a:buNone/>
-            </a:pPr>
-            <a:r>
-              <a:rPr lang="en-US" sz="1800" dirty="0">
-                <a:solidFill>
-                  <a:srgbClr val="C9D6EC"/>
                 </a:solidFill>
                 <a:latin typeface="Arial" pitchFamily="34" charset="0"/>
                 <a:ea typeface="Arial" pitchFamily="34" charset="-122"/>
                 <a:cs typeface="Arial" pitchFamily="34" charset="-120"/>
               </a:rPr>
-              <a:t>name of the sponsor for the conference room, advertising material distribution</a:t>
-            </a:r>
-            <a:endParaRPr lang="en-US" sz="2448" dirty="0"/>
-          </a:p>
-        </p:txBody>
-      </p:sp>
-      <p:sp>
-        <p:nvSpPr>
-          <p:cNvPr id="17" name="Text 13"/>
-          <p:cNvSpPr/>
-          <p:nvPr/>
-        </p:nvSpPr>
-        <p:spPr>
-          <a:xfrm>
-            <a:off x="13716000" y="4005072"/>
-            <a:ext cx="3108960" cy="1243584"/>
-          </a:xfrm>
-          <a:prstGeom prst="rect">
-            <a:avLst/>
-          </a:prstGeom>
-          <a:noFill/>
-          <a:ln/>
-        </p:spPr>
-        <p:txBody>
-          <a:bodyPr wrap="square" lIns="0" tIns="0" rIns="0" bIns="0" rtlCol="0" anchor="ctr"/>
-          <a:lstStyle/>
-          <a:p>
-            <a:pPr algn="ctr" indent="0" marL="0">
-              <a:buNone/>
-            </a:pPr>
-            <a:r>
-              <a:rPr lang="en-US" sz="4608" b="1" dirty="0">
-                <a:solidFill>
-                  <a:srgbClr val="8CCBF2"/>
-                </a:solidFill>
-                <a:latin typeface="Eurostile" pitchFamily="34" charset="0"/>
-                <a:ea typeface="Eurostile" pitchFamily="34" charset="-122"/>
-                <a:cs typeface="Eurostile" pitchFamily="34" charset="-120"/>
-              </a:rPr>
-              <a:t>500</a:t>
-            </a:r>
-            <a:endParaRPr lang="en-US" sz="4608" dirty="0"/>
-          </a:p>
-        </p:txBody>
-      </p:sp>
-      <p:sp>
-        <p:nvSpPr>
-          <p:cNvPr id="18" name="Shape 14"/>
-          <p:cNvSpPr/>
-          <p:nvPr/>
-        </p:nvSpPr>
-        <p:spPr>
-          <a:xfrm>
-            <a:off x="731520" y="5358384"/>
-            <a:ext cx="16093440" cy="1243584"/>
-          </a:xfrm>
-          <a:prstGeom prst="roundRect">
-            <a:avLst>
-              <a:gd name="adj" fmla="val 10294"/>
-            </a:avLst>
-          </a:prstGeom>
-          <a:solidFill>
-            <a:srgbClr val="FFFFFF">
-              <a:alpha val="8000"/>
-            </a:srgbClr>
-          </a:solidFill>
-          <a:ln/>
-        </p:spPr>
-      </p:sp>
-      <p:sp>
-        <p:nvSpPr>
-          <p:cNvPr id="19" name="Shape 15"/>
-          <p:cNvSpPr/>
-          <p:nvPr/>
-        </p:nvSpPr>
-        <p:spPr>
-          <a:xfrm>
-            <a:off x="13716000" y="5358384"/>
-            <a:ext cx="3108960" cy="1243584"/>
-          </a:xfrm>
-          <a:prstGeom prst="rect">
-            <a:avLst/>
-          </a:prstGeom>
-          <a:solidFill>
-            <a:srgbClr val="8CCBF2">
-              <a:alpha val="20000"/>
-            </a:srgbClr>
-          </a:solidFill>
-          <a:ln/>
-        </p:spPr>
-      </p:sp>
-      <p:sp>
-        <p:nvSpPr>
-          <p:cNvPr id="20" name="Text 16"/>
-          <p:cNvSpPr/>
-          <p:nvPr/>
-        </p:nvSpPr>
-        <p:spPr>
-          <a:xfrm>
-            <a:off x="1042416" y="5358384"/>
-            <a:ext cx="12252960" cy="1243584"/>
-          </a:xfrm>
-          <a:prstGeom prst="rect">
-            <a:avLst/>
-          </a:prstGeom>
-          <a:noFill/>
-          <a:ln/>
-        </p:spPr>
-        <p:txBody>
-          <a:bodyPr wrap="square" lIns="0" tIns="0" rIns="0" bIns="0" rtlCol="0" anchor="ctr"/>
-          <a:lstStyle/>
-          <a:p>
-            <a:pPr indent="0" marL="0">
-              <a:buNone/>
-            </a:pPr>
-            <a:r>
-              <a:rPr lang="en-US" sz="2448" b="1" dirty="0">
-                <a:solidFill>
-                  <a:srgbClr val="FFFFFF"/>
-                </a:solidFill>
-                <a:latin typeface="Eurostile" pitchFamily="34" charset="0"/>
-                <a:ea typeface="Eurostile" pitchFamily="34" charset="-122"/>
-                <a:cs typeface="Eurostile" pitchFamily="34" charset="-120"/>
-              </a:rPr>
-              <a:t>Sponsorship of coffee breaks</a:t>
-            </a:r>
-            <a:endParaRPr lang="en-US" sz="2448" dirty="0"/>
-          </a:p>
-          <a:p>
-            <a:pPr indent="0" marL="0">
-              <a:buNone/>
-            </a:pPr>
-            <a:r>
-              <a:rPr lang="en-US" sz="1800" dirty="0">
-                <a:solidFill>
-                  <a:srgbClr val="C9D6EC"/>
-                </a:solidFill>
-                <a:latin typeface="Arial" pitchFamily="34" charset="0"/>
-                <a:ea typeface="Arial" pitchFamily="34" charset="-122"/>
-                <a:cs typeface="Arial" pitchFamily="34" charset="-120"/>
-              </a:rPr>
-              <a:t>name on agenda and announced during apero</a:t>
-            </a:r>
-            <a:endParaRPr lang="en-US" sz="2448" dirty="0"/>
-          </a:p>
-        </p:txBody>
-      </p:sp>
-      <p:sp>
-        <p:nvSpPr>
-          <p:cNvPr id="21" name="Text 17"/>
-          <p:cNvSpPr/>
-          <p:nvPr/>
-        </p:nvSpPr>
-        <p:spPr>
-          <a:xfrm>
-            <a:off x="13716000" y="5358384"/>
-            <a:ext cx="3108960" cy="1243584"/>
-          </a:xfrm>
-          <a:prstGeom prst="rect">
-            <a:avLst/>
-          </a:prstGeom>
-          <a:noFill/>
-          <a:ln/>
-        </p:spPr>
-        <p:txBody>
-          <a:bodyPr wrap="square" lIns="0" tIns="0" rIns="0" bIns="0" rtlCol="0" anchor="ctr"/>
-          <a:lstStyle/>
-          <a:p>
-            <a:pPr algn="ctr" indent="0" marL="0">
-              <a:buNone/>
-            </a:pPr>
-            <a:r>
-              <a:rPr lang="en-US" sz="4608" b="1" dirty="0">
-                <a:solidFill>
-                  <a:srgbClr val="8CCBF2"/>
-                </a:solidFill>
-                <a:latin typeface="Eurostile" pitchFamily="34" charset="0"/>
-                <a:ea typeface="Eurostile" pitchFamily="34" charset="-122"/>
-                <a:cs typeface="Eurostile" pitchFamily="34" charset="-120"/>
-              </a:rPr>
-              <a:t>600</a:t>
-            </a:r>
-            <a:endParaRPr lang="en-US" sz="4608" dirty="0"/>
-          </a:p>
-        </p:txBody>
-      </p:sp>
-      <p:sp>
-        <p:nvSpPr>
-          <p:cNvPr id="22" name="Shape 18"/>
-          <p:cNvSpPr/>
-          <p:nvPr/>
-        </p:nvSpPr>
-        <p:spPr>
-          <a:xfrm>
-            <a:off x="731520" y="6711696"/>
-            <a:ext cx="16093440" cy="1243584"/>
-          </a:xfrm>
-          <a:prstGeom prst="roundRect">
-            <a:avLst>
-              <a:gd name="adj" fmla="val 10294"/>
-            </a:avLst>
-          </a:prstGeom>
-          <a:solidFill>
-            <a:srgbClr val="FFFFFF">
-              <a:alpha val="8000"/>
-            </a:srgbClr>
-          </a:solidFill>
-          <a:ln/>
-        </p:spPr>
-      </p:sp>
-      <p:sp>
-        <p:nvSpPr>
-          <p:cNvPr id="23" name="Shape 19"/>
-          <p:cNvSpPr/>
-          <p:nvPr/>
-        </p:nvSpPr>
-        <p:spPr>
-          <a:xfrm>
-            <a:off x="13716000" y="6711696"/>
-            <a:ext cx="3108960" cy="1243584"/>
-          </a:xfrm>
-          <a:prstGeom prst="rect">
-            <a:avLst/>
-          </a:prstGeom>
-          <a:solidFill>
-            <a:srgbClr val="8CCBF2">
-              <a:alpha val="20000"/>
-            </a:srgbClr>
-          </a:solidFill>
-          <a:ln/>
-        </p:spPr>
-      </p:sp>
-      <p:sp>
-        <p:nvSpPr>
-          <p:cNvPr id="24" name="Text 20"/>
-          <p:cNvSpPr/>
-          <p:nvPr/>
-        </p:nvSpPr>
-        <p:spPr>
-          <a:xfrm>
-            <a:off x="1042416" y="6711696"/>
-            <a:ext cx="12252960" cy="1243584"/>
-          </a:xfrm>
-          <a:prstGeom prst="rect">
-            <a:avLst/>
-          </a:prstGeom>
-          <a:noFill/>
-          <a:ln/>
-        </p:spPr>
-        <p:txBody>
-          <a:bodyPr wrap="square" lIns="0" tIns="0" rIns="0" bIns="0" rtlCol="0" anchor="ctr"/>
-          <a:lstStyle/>
-          <a:p>
-            <a:pPr indent="0" marL="0">
-              <a:buNone/>
-            </a:pPr>
-            <a:r>
-              <a:rPr lang="en-US" sz="2448" b="1" dirty="0">
-                <a:solidFill>
-                  <a:srgbClr val="FFFFFF"/>
-                </a:solidFill>
-                <a:latin typeface="Eurostile" pitchFamily="34" charset="0"/>
-                <a:ea typeface="Eurostile" pitchFamily="34" charset="-122"/>
-                <a:cs typeface="Eurostile" pitchFamily="34" charset="-120"/>
-              </a:rPr>
-              <a:t>Sponsorship of drink catering at the evening Networking Apero</a:t>
-            </a:r>
-            <a:endParaRPr lang="en-US" sz="2448" dirty="0"/>
-          </a:p>
-          <a:p>
-            <a:pPr indent="0" marL="0">
-              <a:buNone/>
-            </a:pPr>
-            <a:r>
-              <a:rPr lang="en-US" sz="1800" dirty="0">
-                <a:solidFill>
-                  <a:srgbClr val="C9D6EC"/>
-                </a:solidFill>
-                <a:latin typeface="Arial" pitchFamily="34" charset="0"/>
-                <a:ea typeface="Arial" pitchFamily="34" charset="-122"/>
-                <a:cs typeface="Arial" pitchFamily="34" charset="-120"/>
-              </a:rPr>
-              <a:t>name on agenda and announced during apero</a:t>
-            </a:r>
-            <a:endParaRPr lang="en-US" sz="2448" dirty="0"/>
-          </a:p>
-        </p:txBody>
-      </p:sp>
-      <p:sp>
-        <p:nvSpPr>
-          <p:cNvPr id="25" name="Text 21"/>
-          <p:cNvSpPr/>
-          <p:nvPr/>
-        </p:nvSpPr>
-        <p:spPr>
-          <a:xfrm>
-            <a:off x="13716000" y="6711696"/>
-            <a:ext cx="3108960" cy="1243584"/>
-          </a:xfrm>
-          <a:prstGeom prst="rect">
-            <a:avLst/>
-          </a:prstGeom>
-          <a:noFill/>
-          <a:ln/>
-        </p:spPr>
-        <p:txBody>
-          <a:bodyPr wrap="square" lIns="0" tIns="0" rIns="0" bIns="0" rtlCol="0" anchor="ctr"/>
-          <a:lstStyle/>
-          <a:p>
-            <a:pPr algn="ctr" indent="0" marL="0">
-              <a:buNone/>
-            </a:pPr>
-            <a:r>
-              <a:rPr lang="en-US" sz="4608" b="1" dirty="0">
-                <a:solidFill>
-                  <a:srgbClr val="8CCBF2"/>
-                </a:solidFill>
-                <a:latin typeface="Eurostile" pitchFamily="34" charset="0"/>
-                <a:ea typeface="Eurostile" pitchFamily="34" charset="-122"/>
-                <a:cs typeface="Eurostile" pitchFamily="34" charset="-120"/>
-              </a:rPr>
-              <a:t>1000</a:t>
-            </a:r>
-            <a:endParaRPr lang="en-US" sz="4608" dirty="0"/>
-          </a:p>
-        </p:txBody>
-      </p:sp>
-      <p:sp>
-        <p:nvSpPr>
-          <p:cNvPr id="26" name="Shape 22"/>
-          <p:cNvSpPr/>
-          <p:nvPr/>
-        </p:nvSpPr>
-        <p:spPr>
-          <a:xfrm>
-            <a:off x="731520" y="8065008"/>
-            <a:ext cx="16093440" cy="1243584"/>
-          </a:xfrm>
-          <a:prstGeom prst="roundRect">
-            <a:avLst>
-              <a:gd name="adj" fmla="val 10294"/>
-            </a:avLst>
-          </a:prstGeom>
-          <a:solidFill>
-            <a:srgbClr val="FFFFFF">
-              <a:alpha val="8000"/>
-            </a:srgbClr>
-          </a:solidFill>
-          <a:ln/>
-        </p:spPr>
-      </p:sp>
-      <p:sp>
-        <p:nvSpPr>
-          <p:cNvPr id="27" name="Shape 23"/>
-          <p:cNvSpPr/>
-          <p:nvPr/>
-        </p:nvSpPr>
-        <p:spPr>
-          <a:xfrm>
-            <a:off x="13716000" y="8065008"/>
-            <a:ext cx="3108960" cy="1243584"/>
-          </a:xfrm>
-          <a:prstGeom prst="rect">
-            <a:avLst/>
-          </a:prstGeom>
-          <a:solidFill>
-            <a:srgbClr val="8CCBF2">
-              <a:alpha val="20000"/>
-            </a:srgbClr>
-          </a:solidFill>
-          <a:ln/>
-        </p:spPr>
-      </p:sp>
-      <p:sp>
-        <p:nvSpPr>
-          <p:cNvPr id="28" name="Text 24"/>
-          <p:cNvSpPr/>
-          <p:nvPr/>
-        </p:nvSpPr>
-        <p:spPr>
-          <a:xfrm>
-            <a:off x="1042416" y="8065008"/>
-            <a:ext cx="12252960" cy="1243584"/>
-          </a:xfrm>
-          <a:prstGeom prst="rect">
-            <a:avLst/>
-          </a:prstGeom>
-          <a:noFill/>
-          <a:ln/>
-        </p:spPr>
-        <p:txBody>
-          <a:bodyPr wrap="square" lIns="0" tIns="0" rIns="0" bIns="0" rtlCol="0" anchor="ctr"/>
-          <a:lstStyle/>
-          <a:p>
-            <a:pPr indent="0" marL="0">
-              <a:buNone/>
-            </a:pPr>
-            <a:r>
-              <a:rPr lang="en-US" sz="2448" b="1" dirty="0">
-                <a:solidFill>
-                  <a:srgbClr val="FFFFFF"/>
-                </a:solidFill>
-                <a:latin typeface="Eurostile" pitchFamily="34" charset="0"/>
-                <a:ea typeface="Eurostile" pitchFamily="34" charset="-122"/>
-                <a:cs typeface="Eurostile" pitchFamily="34" charset="-120"/>
-              </a:rPr>
-              <a:t>Sponsorship for Best Innovation &amp; Science pitch, or Poster winner prizes</a:t>
-            </a:r>
-            <a:endParaRPr lang="en-US" sz="2448" dirty="0"/>
-          </a:p>
-          <a:p>
-            <a:pPr indent="0" marL="0">
-              <a:buNone/>
-            </a:pPr>
-            <a:r>
-              <a:rPr lang="en-US" sz="1800" dirty="0">
-                <a:solidFill>
-                  <a:srgbClr val="C9D6EC"/>
-                </a:solidFill>
-                <a:latin typeface="Arial" pitchFamily="34" charset="0"/>
-                <a:ea typeface="Arial" pitchFamily="34" charset="-122"/>
-                <a:cs typeface="Arial" pitchFamily="34" charset="-120"/>
-              </a:rPr>
-              <a:t>Cash prize or giveaway (e.g. iPad, camera, gift certificate, etc.)</a:t>
-            </a:r>
-            <a:endParaRPr lang="en-US" sz="2448" dirty="0"/>
-          </a:p>
-        </p:txBody>
-      </p:sp>
-      <p:sp>
-        <p:nvSpPr>
-          <p:cNvPr id="29" name="Text 25"/>
-          <p:cNvSpPr/>
-          <p:nvPr/>
-        </p:nvSpPr>
-        <p:spPr>
-          <a:xfrm>
-            <a:off x="13716000" y="8065008"/>
-            <a:ext cx="3108960" cy="1243584"/>
-          </a:xfrm>
-          <a:prstGeom prst="rect">
-            <a:avLst/>
-          </a:prstGeom>
-          <a:noFill/>
-          <a:ln/>
-        </p:spPr>
-        <p:txBody>
-          <a:bodyPr wrap="square" lIns="0" tIns="0" rIns="0" bIns="0" rtlCol="0" anchor="ctr"/>
-          <a:lstStyle/>
-          <a:p>
-            <a:pPr algn="ctr" indent="0" marL="0">
-              <a:buNone/>
-            </a:pPr>
-            <a:r>
-              <a:rPr lang="en-US" sz="2160" b="1" dirty="0">
-                <a:solidFill>
-                  <a:srgbClr val="C9D6EC"/>
-                </a:solidFill>
-                <a:latin typeface="Arial" pitchFamily="34" charset="0"/>
-                <a:ea typeface="Arial" pitchFamily="34" charset="-122"/>
-                <a:cs typeface="Arial" pitchFamily="34" charset="-120"/>
-              </a:rPr>
               <a:t>Open to discussion</a:t>
             </a:r>
-            <a:endParaRPr lang="en-US" sz="2160" dirty="0"/>
+            <a:endParaRPr lang="en-US" sz="3168" dirty="0"/>
           </a:p>
         </p:txBody>
       </p:sp>

</xml_diff>

<commit_message>
Sponsorship packages: final one-page PPTX, PDF and 4K JPG
Co-Authored-By: Claude Sonnet 5.5 <noreply@anthropic.com>
Claude-Session: https://claude.ai/code/session_01Yap9T87JWAqq3mxYKugXQZ
</commit_message>
<xml_diff>
--- a/Logistica_ETH/sponsorship/OILS26_Sponsorship_Packages.pptx
+++ b/Logistica_ETH/sponsorship/OILS26_Sponsorship_Packages.pptx
@@ -6,10 +6,9 @@
   </p:sldMasterIdLst>
   <p:sldIdLst>
     <p:sldId id="256" r:id="rId2"/>
-    <p:sldId id="257" r:id="rId3"/>
   </p:sldIdLst>
   <p:notesMasterIdLst>
-    <p:notesMasterId r:id="rId4"/>
+    <p:notesMasterId r:id="rId3"/>
   </p:notesMasterIdLst>
   <p:sldSz cx="17556480" cy="9875520"/>
   <p:notesSz cx="9875520" cy="17556480"/>
@@ -545,94 +544,6 @@
 </p:notes>
 </file>
 
-<file path=ppt/notesSlides/notesSlide2.xml><?xml version="1.0" encoding="utf-8"?>
-<p:notes xmlns:a="http://schemas.openxmlformats.org/drawingml/2006/main" xmlns:r="http://schemas.openxmlformats.org/officeDocument/2006/relationships" xmlns:p="http://schemas.openxmlformats.org/presentationml/2006/main">
-  <p:cSld>
-    <p:spTree>
-      <p:nvGrpSpPr>
-        <p:cNvPr id="1" name=""/>
-        <p:cNvGrpSpPr/>
-        <p:nvPr/>
-      </p:nvGrpSpPr>
-      <p:grpSpPr>
-        <a:xfrm>
-          <a:off x="0" y="0"/>
-          <a:ext cx="0" cy="0"/>
-          <a:chOff x="0" y="0"/>
-          <a:chExt cx="0" cy="0"/>
-        </a:xfrm>
-      </p:grpSpPr>
-      <p:sp>
-        <p:nvSpPr>
-          <p:cNvPr id="2" name="Slide Image Placeholder 1"/>
-          <p:cNvSpPr>
-            <a:spLocks noGrp="1" noRot="1" noChangeAspect="1"/>
-          </p:cNvSpPr>
-          <p:nvPr>
-            <p:ph type="sldImg"/>
-          </p:nvPr>
-        </p:nvSpPr>
-        <p:spPr/>
-      </p:sp>
-      <p:sp>
-        <p:nvSpPr>
-          <p:cNvPr id="3" name="Notes Placeholder 2"/>
-          <p:cNvSpPr>
-            <a:spLocks noGrp="1"/>
-          </p:cNvSpPr>
-          <p:nvPr>
-            <p:ph type="body" idx="1"/>
-          </p:nvPr>
-        </p:nvSpPr>
-        <p:spPr/>
-        <p:txBody>
-          <a:bodyPr/>
-          <a:lstStyle/>
-          <a:p>
-            <a:r>
-              <a:rPr lang="en-US" dirty="0"/>
-              <a:t/>
-            </a:r>
-            <a:endParaRPr lang="en-US" dirty="0"/>
-          </a:p>
-        </p:txBody>
-      </p:sp>
-      <p:sp>
-        <p:nvSpPr>
-          <p:cNvPr id="4" name="Slide Number Placeholder 3"/>
-          <p:cNvSpPr>
-            <a:spLocks noGrp="1"/>
-          </p:cNvSpPr>
-          <p:nvPr>
-            <p:ph type="sldNum" sz="quarter" idx="10"/>
-          </p:nvPr>
-        </p:nvSpPr>
-        <p:spPr/>
-        <p:txBody>
-          <a:bodyPr/>
-          <a:lstStyle/>
-          <a:p>
-            <a:fld id="{F7021451-1387-4CA6-816F-3879F97B5CBC}" type="slidenum">
-              <a:rPr lang="en-US"/>
-              <a:t>2</a:t>
-            </a:fld>
-            <a:endParaRPr lang="en-US"/>
-          </a:p>
-        </p:txBody>
-      </p:sp>
-    </p:spTree>
-    <p:extLst>
-      <p:ext uri="{BB962C8B-B14F-4D97-AF65-F5344CB8AC3E}">
-        <p14:creationId xmlns:p14="http://schemas.microsoft.com/office/powerpoint/2010/main" val="1024086991"/>
-      </p:ext>
-    </p:extLst>
-  </p:cSld>
-  <p:clrMapOvr>
-    <a:masterClrMapping/>
-  </p:clrMapOvr>
-</p:notes>
-</file>
-
 <file path=ppt/slideLayouts/slideLayout1.xml><?xml version="1.0" encoding="utf-8"?>
 <p:sldLayout xmlns:a="http://schemas.openxmlformats.org/drawingml/2006/main" xmlns:r="http://schemas.openxmlformats.org/officeDocument/2006/relationships" xmlns:p="http://schemas.openxmlformats.org/presentationml/2006/main" preserve="1">
   <p:cSld name="DEFAULT">
@@ -1173,8 +1084,8 @@
         </p:nvSpPr>
         <p:spPr>
           <a:xfrm>
-            <a:off x="10104120" y="1883664"/>
-            <a:ext cx="1645920" cy="1078992"/>
+            <a:off x="10104120" y="1737360"/>
+            <a:ext cx="1645920" cy="950976"/>
           </a:xfrm>
           <a:prstGeom prst="round2SameRect">
             <a:avLst/>
@@ -1193,8 +1104,8 @@
         </p:nvSpPr>
         <p:spPr>
           <a:xfrm>
-            <a:off x="10104120" y="1883664"/>
-            <a:ext cx="1645920" cy="1078992"/>
+            <a:off x="10104120" y="1737360"/>
+            <a:ext cx="1645920" cy="950976"/>
           </a:xfrm>
           <a:prstGeom prst="rect">
             <a:avLst/>
@@ -1249,8 +1160,8 @@
         </p:nvSpPr>
         <p:spPr>
           <a:xfrm>
-            <a:off x="11795760" y="1883664"/>
-            <a:ext cx="1645920" cy="1078992"/>
+            <a:off x="11786616" y="1737360"/>
+            <a:ext cx="1645920" cy="950976"/>
           </a:xfrm>
           <a:prstGeom prst="round2SameRect">
             <a:avLst/>
@@ -1269,8 +1180,8 @@
         </p:nvSpPr>
         <p:spPr>
           <a:xfrm>
-            <a:off x="11795760" y="1883664"/>
-            <a:ext cx="1645920" cy="1078992"/>
+            <a:off x="11786616" y="1737360"/>
+            <a:ext cx="1645920" cy="950976"/>
           </a:xfrm>
           <a:prstGeom prst="rect">
             <a:avLst/>
@@ -1325,8 +1236,8 @@
         </p:nvSpPr>
         <p:spPr>
           <a:xfrm>
-            <a:off x="13487400" y="1883664"/>
-            <a:ext cx="1645920" cy="1078992"/>
+            <a:off x="13469112" y="1737360"/>
+            <a:ext cx="1645920" cy="950976"/>
           </a:xfrm>
           <a:prstGeom prst="round2SameRect">
             <a:avLst/>
@@ -1345,8 +1256,8 @@
         </p:nvSpPr>
         <p:spPr>
           <a:xfrm>
-            <a:off x="13487400" y="1883664"/>
-            <a:ext cx="1645920" cy="1078992"/>
+            <a:off x="13469112" y="1737360"/>
+            <a:ext cx="1645920" cy="950976"/>
           </a:xfrm>
           <a:prstGeom prst="rect">
             <a:avLst/>
@@ -1401,8 +1312,8 @@
         </p:nvSpPr>
         <p:spPr>
           <a:xfrm>
-            <a:off x="15179040" y="1883664"/>
-            <a:ext cx="1645920" cy="1078992"/>
+            <a:off x="15151608" y="1737360"/>
+            <a:ext cx="1645920" cy="950976"/>
           </a:xfrm>
           <a:prstGeom prst="round2SameRect">
             <a:avLst/>
@@ -1421,8 +1332,8 @@
         </p:nvSpPr>
         <p:spPr>
           <a:xfrm>
-            <a:off x="15179040" y="1883664"/>
-            <a:ext cx="1645920" cy="1078992"/>
+            <a:off x="15151608" y="1737360"/>
+            <a:ext cx="1645920" cy="950976"/>
           </a:xfrm>
           <a:prstGeom prst="rect">
             <a:avLst/>
@@ -1477,12 +1388,12 @@
         </p:nvSpPr>
         <p:spPr>
           <a:xfrm>
-            <a:off x="731520" y="3035808"/>
-            <a:ext cx="16093440" cy="713232"/>
+            <a:off x="731520" y="2743200"/>
+            <a:ext cx="16093440" cy="621792"/>
           </a:xfrm>
           <a:prstGeom prst="roundRect">
             <a:avLst>
-              <a:gd name="adj" fmla="val 17949"/>
+              <a:gd name="adj" fmla="val 20588"/>
             </a:avLst>
           </a:prstGeom>
           <a:solidFill>
@@ -1501,8 +1412,8 @@
         </p:nvSpPr>
         <p:spPr>
           <a:xfrm>
-            <a:off x="1042416" y="3035808"/>
-            <a:ext cx="8778240" cy="713232"/>
+            <a:off x="1042416" y="2743200"/>
+            <a:ext cx="8778240" cy="621792"/>
           </a:xfrm>
           <a:prstGeom prst="rect">
             <a:avLst/>
@@ -1543,8 +1454,8 @@
         </p:nvSpPr>
         <p:spPr>
           <a:xfrm>
-            <a:off x="10104120" y="3035808"/>
-            <a:ext cx="1645920" cy="713232"/>
+            <a:off x="10104120" y="2743200"/>
+            <a:ext cx="1645920" cy="621792"/>
           </a:xfrm>
           <a:prstGeom prst="rect">
             <a:avLst/>
@@ -1565,7 +1476,7 @@
         </p:nvSpPr>
         <p:spPr>
           <a:xfrm>
-            <a:off x="10735056" y="3200400"/>
+            <a:off x="10735056" y="2862072"/>
             <a:ext cx="384048" cy="384048"/>
           </a:xfrm>
           <a:prstGeom prst="ellipse">
@@ -1585,7 +1496,7 @@
         </p:nvSpPr>
         <p:spPr>
           <a:xfrm>
-            <a:off x="10735056" y="3200400"/>
+            <a:off x="10735056" y="2862072"/>
             <a:ext cx="384048" cy="384048"/>
           </a:xfrm>
           <a:prstGeom prst="rect">
@@ -1624,8 +1535,8 @@
         </p:nvSpPr>
         <p:spPr>
           <a:xfrm>
-            <a:off x="11795760" y="3035808"/>
-            <a:ext cx="1645920" cy="713232"/>
+            <a:off x="11786616" y="2743200"/>
+            <a:ext cx="1645920" cy="621792"/>
           </a:xfrm>
           <a:prstGeom prst="rect">
             <a:avLst/>
@@ -1646,7 +1557,7 @@
         </p:nvSpPr>
         <p:spPr>
           <a:xfrm>
-            <a:off x="12426696" y="3200400"/>
+            <a:off x="12417552" y="2862072"/>
             <a:ext cx="384048" cy="384048"/>
           </a:xfrm>
           <a:prstGeom prst="ellipse">
@@ -1666,7 +1577,7 @@
         </p:nvSpPr>
         <p:spPr>
           <a:xfrm>
-            <a:off x="12426696" y="3200400"/>
+            <a:off x="12417552" y="2862072"/>
             <a:ext cx="384048" cy="384048"/>
           </a:xfrm>
           <a:prstGeom prst="rect">
@@ -1705,8 +1616,8 @@
         </p:nvSpPr>
         <p:spPr>
           <a:xfrm>
-            <a:off x="13487400" y="3035808"/>
-            <a:ext cx="1645920" cy="713232"/>
+            <a:off x="13469112" y="2743200"/>
+            <a:ext cx="1645920" cy="621792"/>
           </a:xfrm>
           <a:prstGeom prst="rect">
             <a:avLst/>
@@ -1727,7 +1638,7 @@
         </p:nvSpPr>
         <p:spPr>
           <a:xfrm>
-            <a:off x="14118336" y="3200400"/>
+            <a:off x="14100048" y="2862072"/>
             <a:ext cx="384048" cy="384048"/>
           </a:xfrm>
           <a:prstGeom prst="ellipse">
@@ -1747,7 +1658,7 @@
         </p:nvSpPr>
         <p:spPr>
           <a:xfrm>
-            <a:off x="14118336" y="3200400"/>
+            <a:off x="14100048" y="2862072"/>
             <a:ext cx="384048" cy="384048"/>
           </a:xfrm>
           <a:prstGeom prst="rect">
@@ -1786,12 +1697,12 @@
         </p:nvSpPr>
         <p:spPr>
           <a:xfrm>
-            <a:off x="731520" y="3794760"/>
-            <a:ext cx="16093440" cy="713232"/>
+            <a:off x="731520" y="3401568"/>
+            <a:ext cx="16093440" cy="621792"/>
           </a:xfrm>
           <a:prstGeom prst="roundRect">
             <a:avLst>
-              <a:gd name="adj" fmla="val 17949"/>
+              <a:gd name="adj" fmla="val 20588"/>
             </a:avLst>
           </a:prstGeom>
           <a:solidFill>
@@ -1810,8 +1721,8 @@
         </p:nvSpPr>
         <p:spPr>
           <a:xfrm>
-            <a:off x="1042416" y="3794760"/>
-            <a:ext cx="8778240" cy="713232"/>
+            <a:off x="1042416" y="3401568"/>
+            <a:ext cx="8778240" cy="621792"/>
           </a:xfrm>
           <a:prstGeom prst="rect">
             <a:avLst/>
@@ -1852,8 +1763,8 @@
         </p:nvSpPr>
         <p:spPr>
           <a:xfrm>
-            <a:off x="10104120" y="3794760"/>
-            <a:ext cx="1645920" cy="713232"/>
+            <a:off x="10104120" y="3401568"/>
+            <a:ext cx="1645920" cy="621792"/>
           </a:xfrm>
           <a:prstGeom prst="rect">
             <a:avLst/>
@@ -1874,7 +1785,7 @@
         </p:nvSpPr>
         <p:spPr>
           <a:xfrm>
-            <a:off x="10735056" y="3959352"/>
+            <a:off x="10735056" y="3520440"/>
             <a:ext cx="384048" cy="384048"/>
           </a:xfrm>
           <a:prstGeom prst="ellipse">
@@ -1894,7 +1805,7 @@
         </p:nvSpPr>
         <p:spPr>
           <a:xfrm>
-            <a:off x="10735056" y="3959352"/>
+            <a:off x="10735056" y="3520440"/>
             <a:ext cx="384048" cy="384048"/>
           </a:xfrm>
           <a:prstGeom prst="rect">
@@ -1933,8 +1844,8 @@
         </p:nvSpPr>
         <p:spPr>
           <a:xfrm>
-            <a:off x="11795760" y="3794760"/>
-            <a:ext cx="1645920" cy="713232"/>
+            <a:off x="11786616" y="3401568"/>
+            <a:ext cx="1645920" cy="621792"/>
           </a:xfrm>
           <a:prstGeom prst="rect">
             <a:avLst/>
@@ -1955,7 +1866,7 @@
         </p:nvSpPr>
         <p:spPr>
           <a:xfrm>
-            <a:off x="12426696" y="3959352"/>
+            <a:off x="12417552" y="3520440"/>
             <a:ext cx="384048" cy="384048"/>
           </a:xfrm>
           <a:prstGeom prst="ellipse">
@@ -1975,7 +1886,7 @@
         </p:nvSpPr>
         <p:spPr>
           <a:xfrm>
-            <a:off x="12426696" y="3959352"/>
+            <a:off x="12417552" y="3520440"/>
             <a:ext cx="384048" cy="384048"/>
           </a:xfrm>
           <a:prstGeom prst="rect">
@@ -2014,8 +1925,8 @@
         </p:nvSpPr>
         <p:spPr>
           <a:xfrm>
-            <a:off x="13487400" y="3794760"/>
-            <a:ext cx="1645920" cy="713232"/>
+            <a:off x="13469112" y="3401568"/>
+            <a:ext cx="1645920" cy="621792"/>
           </a:xfrm>
           <a:prstGeom prst="rect">
             <a:avLst/>
@@ -2036,7 +1947,7 @@
         </p:nvSpPr>
         <p:spPr>
           <a:xfrm>
-            <a:off x="14118336" y="3959352"/>
+            <a:off x="14100048" y="3520440"/>
             <a:ext cx="384048" cy="384048"/>
           </a:xfrm>
           <a:prstGeom prst="ellipse">
@@ -2056,7 +1967,7 @@
         </p:nvSpPr>
         <p:spPr>
           <a:xfrm>
-            <a:off x="14118336" y="3959352"/>
+            <a:off x="14100048" y="3520440"/>
             <a:ext cx="384048" cy="384048"/>
           </a:xfrm>
           <a:prstGeom prst="rect">
@@ -2095,12 +2006,12 @@
         </p:nvSpPr>
         <p:spPr>
           <a:xfrm>
-            <a:off x="731520" y="4553712"/>
-            <a:ext cx="16093440" cy="713232"/>
+            <a:off x="731520" y="4059936"/>
+            <a:ext cx="16093440" cy="621792"/>
           </a:xfrm>
           <a:prstGeom prst="roundRect">
             <a:avLst>
-              <a:gd name="adj" fmla="val 17949"/>
+              <a:gd name="adj" fmla="val 20588"/>
             </a:avLst>
           </a:prstGeom>
           <a:solidFill>
@@ -2119,8 +2030,8 @@
         </p:nvSpPr>
         <p:spPr>
           <a:xfrm>
-            <a:off x="1042416" y="4553712"/>
-            <a:ext cx="8778240" cy="713232"/>
+            <a:off x="1042416" y="4059936"/>
+            <a:ext cx="8778240" cy="621792"/>
           </a:xfrm>
           <a:prstGeom prst="rect">
             <a:avLst/>
@@ -2161,8 +2072,8 @@
         </p:nvSpPr>
         <p:spPr>
           <a:xfrm>
-            <a:off x="11795760" y="4553712"/>
-            <a:ext cx="1645920" cy="713232"/>
+            <a:off x="11786616" y="4059936"/>
+            <a:ext cx="1645920" cy="621792"/>
           </a:xfrm>
           <a:prstGeom prst="rect">
             <a:avLst/>
@@ -2183,7 +2094,7 @@
         </p:nvSpPr>
         <p:spPr>
           <a:xfrm>
-            <a:off x="12426696" y="4718304"/>
+            <a:off x="12417552" y="4178808"/>
             <a:ext cx="384048" cy="384048"/>
           </a:xfrm>
           <a:prstGeom prst="ellipse">
@@ -2203,7 +2114,7 @@
         </p:nvSpPr>
         <p:spPr>
           <a:xfrm>
-            <a:off x="12426696" y="4718304"/>
+            <a:off x="12417552" y="4178808"/>
             <a:ext cx="384048" cy="384048"/>
           </a:xfrm>
           <a:prstGeom prst="rect">
@@ -2242,8 +2153,8 @@
         </p:nvSpPr>
         <p:spPr>
           <a:xfrm>
-            <a:off x="13487400" y="4553712"/>
-            <a:ext cx="1645920" cy="713232"/>
+            <a:off x="13469112" y="4059936"/>
+            <a:ext cx="1645920" cy="621792"/>
           </a:xfrm>
           <a:prstGeom prst="rect">
             <a:avLst/>
@@ -2264,7 +2175,7 @@
         </p:nvSpPr>
         <p:spPr>
           <a:xfrm>
-            <a:off x="14118336" y="4718304"/>
+            <a:off x="14100048" y="4178808"/>
             <a:ext cx="384048" cy="384048"/>
           </a:xfrm>
           <a:prstGeom prst="ellipse">
@@ -2284,7 +2195,7 @@
         </p:nvSpPr>
         <p:spPr>
           <a:xfrm>
-            <a:off x="14118336" y="4718304"/>
+            <a:off x="14100048" y="4178808"/>
             <a:ext cx="384048" cy="384048"/>
           </a:xfrm>
           <a:prstGeom prst="rect">
@@ -2323,12 +2234,12 @@
         </p:nvSpPr>
         <p:spPr>
           <a:xfrm>
-            <a:off x="731520" y="5312664"/>
-            <a:ext cx="16093440" cy="713232"/>
+            <a:off x="731520" y="4718304"/>
+            <a:ext cx="16093440" cy="621792"/>
           </a:xfrm>
           <a:prstGeom prst="roundRect">
             <a:avLst>
-              <a:gd name="adj" fmla="val 17949"/>
+              <a:gd name="adj" fmla="val 20588"/>
             </a:avLst>
           </a:prstGeom>
           <a:solidFill>
@@ -2347,8 +2258,8 @@
         </p:nvSpPr>
         <p:spPr>
           <a:xfrm>
-            <a:off x="1042416" y="5312664"/>
-            <a:ext cx="8778240" cy="713232"/>
+            <a:off x="1042416" y="4718304"/>
+            <a:ext cx="8778240" cy="621792"/>
           </a:xfrm>
           <a:prstGeom prst="rect">
             <a:avLst/>
@@ -2389,8 +2300,8 @@
         </p:nvSpPr>
         <p:spPr>
           <a:xfrm>
-            <a:off x="11795760" y="5312664"/>
-            <a:ext cx="1645920" cy="713232"/>
+            <a:off x="11786616" y="4718304"/>
+            <a:ext cx="1645920" cy="621792"/>
           </a:xfrm>
           <a:prstGeom prst="rect">
             <a:avLst/>
@@ -2411,7 +2322,7 @@
         </p:nvSpPr>
         <p:spPr>
           <a:xfrm>
-            <a:off x="12426696" y="5477256"/>
+            <a:off x="12417552" y="4837176"/>
             <a:ext cx="384048" cy="384048"/>
           </a:xfrm>
           <a:prstGeom prst="ellipse">
@@ -2431,7 +2342,7 @@
         </p:nvSpPr>
         <p:spPr>
           <a:xfrm>
-            <a:off x="12426696" y="5477256"/>
+            <a:off x="12417552" y="4837176"/>
             <a:ext cx="384048" cy="384048"/>
           </a:xfrm>
           <a:prstGeom prst="rect">
@@ -2470,12 +2381,12 @@
         </p:nvSpPr>
         <p:spPr>
           <a:xfrm>
-            <a:off x="731520" y="6071616"/>
-            <a:ext cx="16093440" cy="713232"/>
+            <a:off x="731520" y="5376672"/>
+            <a:ext cx="16093440" cy="621792"/>
           </a:xfrm>
           <a:prstGeom prst="roundRect">
             <a:avLst>
-              <a:gd name="adj" fmla="val 17949"/>
+              <a:gd name="adj" fmla="val 20588"/>
             </a:avLst>
           </a:prstGeom>
           <a:solidFill>
@@ -2494,8 +2405,8 @@
         </p:nvSpPr>
         <p:spPr>
           <a:xfrm>
-            <a:off x="1042416" y="6071616"/>
-            <a:ext cx="8778240" cy="713232"/>
+            <a:off x="1042416" y="5376672"/>
+            <a:ext cx="8778240" cy="621792"/>
           </a:xfrm>
           <a:prstGeom prst="rect">
             <a:avLst/>
@@ -2536,8 +2447,8 @@
         </p:nvSpPr>
         <p:spPr>
           <a:xfrm>
-            <a:off x="13487400" y="6071616"/>
-            <a:ext cx="1645920" cy="713232"/>
+            <a:off x="13469112" y="5376672"/>
+            <a:ext cx="1645920" cy="621792"/>
           </a:xfrm>
           <a:prstGeom prst="rect">
             <a:avLst/>
@@ -2558,7 +2469,7 @@
         </p:nvSpPr>
         <p:spPr>
           <a:xfrm>
-            <a:off x="14118336" y="6236208"/>
+            <a:off x="14100048" y="5495544"/>
             <a:ext cx="384048" cy="384048"/>
           </a:xfrm>
           <a:prstGeom prst="ellipse">
@@ -2578,7 +2489,7 @@
         </p:nvSpPr>
         <p:spPr>
           <a:xfrm>
-            <a:off x="14118336" y="6236208"/>
+            <a:off x="14100048" y="5495544"/>
             <a:ext cx="384048" cy="384048"/>
           </a:xfrm>
           <a:prstGeom prst="rect">
@@ -2617,12 +2528,12 @@
         </p:nvSpPr>
         <p:spPr>
           <a:xfrm>
-            <a:off x="731520" y="6830568"/>
-            <a:ext cx="16093440" cy="713232"/>
+            <a:off x="731520" y="6035040"/>
+            <a:ext cx="16093440" cy="621792"/>
           </a:xfrm>
           <a:prstGeom prst="roundRect">
             <a:avLst>
-              <a:gd name="adj" fmla="val 17949"/>
+              <a:gd name="adj" fmla="val 20588"/>
             </a:avLst>
           </a:prstGeom>
           <a:solidFill>
@@ -2641,8 +2552,8 @@
         </p:nvSpPr>
         <p:spPr>
           <a:xfrm>
-            <a:off x="1042416" y="6830568"/>
-            <a:ext cx="8778240" cy="713232"/>
+            <a:off x="1042416" y="6035040"/>
+            <a:ext cx="8778240" cy="621792"/>
           </a:xfrm>
           <a:prstGeom prst="rect">
             <a:avLst/>
@@ -2683,8 +2594,8 @@
         </p:nvSpPr>
         <p:spPr>
           <a:xfrm>
-            <a:off x="13487400" y="6830568"/>
-            <a:ext cx="1645920" cy="713232"/>
+            <a:off x="13469112" y="6035040"/>
+            <a:ext cx="1645920" cy="621792"/>
           </a:xfrm>
           <a:prstGeom prst="rect">
             <a:avLst/>
@@ -2705,7 +2616,7 @@
         </p:nvSpPr>
         <p:spPr>
           <a:xfrm>
-            <a:off x="14118336" y="6995160"/>
+            <a:off x="14100048" y="6153912"/>
             <a:ext cx="384048" cy="384048"/>
           </a:xfrm>
           <a:prstGeom prst="ellipse">
@@ -2725,7 +2636,7 @@
         </p:nvSpPr>
         <p:spPr>
           <a:xfrm>
-            <a:off x="14118336" y="6995160"/>
+            <a:off x="14100048" y="6153912"/>
             <a:ext cx="384048" cy="384048"/>
           </a:xfrm>
           <a:prstGeom prst="rect">
@@ -2764,12 +2675,12 @@
         </p:nvSpPr>
         <p:spPr>
           <a:xfrm>
-            <a:off x="731520" y="7589520"/>
-            <a:ext cx="16093440" cy="713232"/>
+            <a:off x="731520" y="6693408"/>
+            <a:ext cx="16093440" cy="621792"/>
           </a:xfrm>
           <a:prstGeom prst="roundRect">
             <a:avLst>
-              <a:gd name="adj" fmla="val 17949"/>
+              <a:gd name="adj" fmla="val 20588"/>
             </a:avLst>
           </a:prstGeom>
           <a:solidFill>
@@ -2788,8 +2699,8 @@
         </p:nvSpPr>
         <p:spPr>
           <a:xfrm>
-            <a:off x="1042416" y="7589520"/>
-            <a:ext cx="8778240" cy="713232"/>
+            <a:off x="1042416" y="6693408"/>
+            <a:ext cx="8778240" cy="621792"/>
           </a:xfrm>
           <a:prstGeom prst="rect">
             <a:avLst/>
@@ -2830,8 +2741,8 @@
         </p:nvSpPr>
         <p:spPr>
           <a:xfrm>
-            <a:off x="13487400" y="7589520"/>
-            <a:ext cx="1645920" cy="713232"/>
+            <a:off x="13469112" y="6693408"/>
+            <a:ext cx="1645920" cy="621792"/>
           </a:xfrm>
           <a:prstGeom prst="rect">
             <a:avLst/>
@@ -2852,7 +2763,7 @@
         </p:nvSpPr>
         <p:spPr>
           <a:xfrm>
-            <a:off x="14118336" y="7754112"/>
+            <a:off x="14100048" y="6812280"/>
             <a:ext cx="384048" cy="384048"/>
           </a:xfrm>
           <a:prstGeom prst="ellipse">
@@ -2872,7 +2783,7 @@
         </p:nvSpPr>
         <p:spPr>
           <a:xfrm>
-            <a:off x="14118336" y="7754112"/>
+            <a:off x="14100048" y="6812280"/>
             <a:ext cx="384048" cy="384048"/>
           </a:xfrm>
           <a:prstGeom prst="rect">
@@ -2911,12 +2822,12 @@
         </p:nvSpPr>
         <p:spPr>
           <a:xfrm>
-            <a:off x="731520" y="8348472"/>
-            <a:ext cx="16093440" cy="713232"/>
+            <a:off x="731520" y="7351776"/>
+            <a:ext cx="16093440" cy="621792"/>
           </a:xfrm>
           <a:prstGeom prst="roundRect">
             <a:avLst>
-              <a:gd name="adj" fmla="val 17949"/>
+              <a:gd name="adj" fmla="val 20588"/>
             </a:avLst>
           </a:prstGeom>
           <a:solidFill>
@@ -2935,8 +2846,8 @@
         </p:nvSpPr>
         <p:spPr>
           <a:xfrm>
-            <a:off x="1042416" y="8348472"/>
-            <a:ext cx="8778240" cy="713232"/>
+            <a:off x="1042416" y="7351776"/>
+            <a:ext cx="8778240" cy="621792"/>
           </a:xfrm>
           <a:prstGeom prst="rect">
             <a:avLst/>
@@ -2977,8 +2888,8 @@
         </p:nvSpPr>
         <p:spPr>
           <a:xfrm>
-            <a:off x="15179040" y="8348472"/>
-            <a:ext cx="1645920" cy="713232"/>
+            <a:off x="15151608" y="7351776"/>
+            <a:ext cx="1645920" cy="621792"/>
           </a:xfrm>
           <a:prstGeom prst="rect">
             <a:avLst/>
@@ -2999,7 +2910,7 @@
         </p:nvSpPr>
         <p:spPr>
           <a:xfrm>
-            <a:off x="15809976" y="8513064"/>
+            <a:off x="15782544" y="7470648"/>
             <a:ext cx="384048" cy="384048"/>
           </a:xfrm>
           <a:prstGeom prst="ellipse">
@@ -3019,7 +2930,7 @@
         </p:nvSpPr>
         <p:spPr>
           <a:xfrm>
-            <a:off x="15809976" y="8513064"/>
+            <a:off x="15782544" y="7470648"/>
             <a:ext cx="384048" cy="384048"/>
           </a:xfrm>
           <a:prstGeom prst="rect">
@@ -3050,118 +2961,62 @@
           </a:p>
         </p:txBody>
       </p:sp>
-    </p:spTree>
-  </p:cSld>
-  <p:clrMapOvr>
-    <a:masterClrMapping/>
-  </p:clrMapOvr>
-</p:sld>
-</file>
-
-<file path=ppt/slides/slide2.xml><?xml version="1.0" encoding="utf-8"?>
-<p:sld xmlns:a="http://schemas.openxmlformats.org/drawingml/2006/main" xmlns:r="http://schemas.openxmlformats.org/officeDocument/2006/relationships" xmlns:p="http://schemas.openxmlformats.org/presentationml/2006/main">
-  <p:cSld name="Slide 2">
-    <p:bg>
-      <p:bgPr>
-        <a:solidFill>
-          <a:srgbClr val="061433"/>
-        </a:solidFill>
-      </p:bgPr>
-    </p:bg>
-    <p:spTree>
-      <p:nvGrpSpPr>
-        <p:cNvPr id="1" name=""/>
-        <p:cNvGrpSpPr/>
-        <p:nvPr/>
-      </p:nvGrpSpPr>
-      <p:grpSpPr>
-        <a:xfrm>
-          <a:off x="0" y="0"/>
-          <a:ext cx="0" cy="0"/>
-          <a:chOff x="0" y="0"/>
-          <a:chExt cx="0" cy="0"/>
-        </a:xfrm>
-      </p:grpSpPr>
-      <p:pic>
-        <p:nvPicPr>
-          <p:cNvPr id="2" name="Image 0" descr="OILS pattern background">    </p:cNvPr>
-          <p:cNvPicPr>
-            <a:picLocks noChangeAspect="1"/>
-          </p:cNvPicPr>
-          <p:nvPr/>
-        </p:nvPicPr>
-        <p:blipFill>
-          <a:blip r:embed="rId1"/>
-          <a:stretch>
-            <a:fillRect/>
-          </a:stretch>
-        </p:blipFill>
-        <p:spPr>
-          <a:xfrm>
-            <a:off x="0" y="0"/>
-            <a:ext cx="17556480" cy="9875520"/>
-          </a:xfrm>
-          <a:prstGeom prst="rect">
-            <a:avLst/>
-          </a:prstGeom>
-        </p:spPr>
-      </p:pic>
-      <p:sp>
-        <p:nvSpPr>
-          <p:cNvPr id="3" name="Shape 0"/>
-          <p:cNvSpPr/>
-          <p:nvPr/>
-        </p:nvSpPr>
-        <p:spPr>
-          <a:xfrm>
-            <a:off x="0" y="0"/>
-            <a:ext cx="17556480" cy="9875520"/>
-          </a:xfrm>
-          <a:prstGeom prst="rect">
-            <a:avLst/>
-          </a:prstGeom>
-          <a:solidFill>
-            <a:srgbClr val="061433">
-              <a:alpha val="78000"/>
+      <p:sp>
+        <p:nvSpPr>
+          <p:cNvPr id="71" name="Shape 67"/>
+          <p:cNvSpPr/>
+          <p:nvPr/>
+        </p:nvSpPr>
+        <p:spPr>
+          <a:xfrm>
+            <a:off x="731520" y="8156448"/>
+            <a:ext cx="16093440" cy="1024128"/>
+          </a:xfrm>
+          <a:prstGeom prst="roundRect">
+            <a:avLst>
+              <a:gd name="adj" fmla="val 12500"/>
+            </a:avLst>
+          </a:prstGeom>
+          <a:solidFill>
+            <a:srgbClr val="FFFFFF">
+              <a:alpha val="8000"/>
             </a:srgbClr>
           </a:solidFill>
           <a:ln/>
         </p:spPr>
       </p:sp>
-      <p:pic>
-        <p:nvPicPr>
-          <p:cNvPr id="4" name="Image 1" descr="OILS logo">    </p:cNvPr>
-          <p:cNvPicPr>
-            <a:picLocks noChangeAspect="1"/>
-          </p:cNvPicPr>
-          <p:nvPr/>
-        </p:nvPicPr>
-        <p:blipFill>
-          <a:blip r:embed="rId2"/>
-          <a:stretch>
-            <a:fillRect/>
-          </a:stretch>
-        </p:blipFill>
-        <p:spPr>
-          <a:xfrm>
-            <a:off x="731520" y="438912"/>
-            <a:ext cx="2103120" cy="941832"/>
-          </a:xfrm>
-          <a:prstGeom prst="rect">
-            <a:avLst/>
-          </a:prstGeom>
-        </p:spPr>
-      </p:pic>
-      <p:sp>
-        <p:nvSpPr>
-          <p:cNvPr id="5" name="Text 1"/>
-          <p:cNvSpPr/>
-          <p:nvPr/>
-        </p:nvSpPr>
-        <p:spPr>
-          <a:xfrm>
-            <a:off x="3200400" y="329184"/>
-            <a:ext cx="13258800" cy="914400"/>
+      <p:sp>
+        <p:nvSpPr>
+          <p:cNvPr id="72" name="Shape 68"/>
+          <p:cNvSpPr/>
+          <p:nvPr/>
+        </p:nvSpPr>
+        <p:spPr>
+          <a:xfrm>
+            <a:off x="12618720" y="8156448"/>
+            <a:ext cx="4206240" cy="1024128"/>
+          </a:xfrm>
+          <a:prstGeom prst="rect">
+            <a:avLst/>
+          </a:prstGeom>
+          <a:solidFill>
+            <a:srgbClr val="8CCBF2">
+              <a:alpha val="20000"/>
+            </a:srgbClr>
+          </a:solidFill>
+          <a:ln/>
+        </p:spPr>
+      </p:sp>
+      <p:sp>
+        <p:nvSpPr>
+          <p:cNvPr id="73" name="Text 69"/>
+          <p:cNvSpPr/>
+          <p:nvPr/>
+        </p:nvSpPr>
+        <p:spPr>
+          <a:xfrm>
+            <a:off x="1042416" y="8156448"/>
+            <a:ext cx="11338560" cy="1024128"/>
           </a:xfrm>
           <a:prstGeom prst="rect">
             <a:avLst/>
@@ -3177,7 +3032,24 @@
               <a:buNone/>
             </a:pPr>
             <a:r>
-              <a:rPr lang="en-US" sz="5472" b="1" dirty="0">
+              <a:rPr lang="en-US" sz="1440" b="1" spc="300" kern="0" dirty="0">
+                <a:solidFill>
+                  <a:srgbClr val="8CCBF2"/>
+                </a:solidFill>
+                <a:latin typeface="Arial" pitchFamily="34" charset="0"/>
+                <a:ea typeface="Arial" pitchFamily="34" charset="-122"/>
+                <a:cs typeface="Arial" pitchFamily="34" charset="-120"/>
+              </a:rPr>
+              <a:t>ADDITIONAL OFFER</a:t>
+            </a:r>
+            <a:endParaRPr lang="en-US" sz="1440" dirty="0"/>
+          </a:p>
+          <a:p>
+            <a:pPr indent="0" marL="0">
+              <a:buNone/>
+            </a:pPr>
+            <a:r>
+              <a:rPr lang="en-US" sz="2304" b="1" dirty="0">
                 <a:solidFill>
                   <a:srgbClr val="FFFFFF"/>
                 </a:solidFill>
@@ -3185,52 +3057,16 @@
                 <a:ea typeface="Eurostile" pitchFamily="34" charset="-122"/>
                 <a:cs typeface="Eurostile" pitchFamily="34" charset="-120"/>
               </a:rPr>
-              <a:t>How to support us </a:t>
-            </a:r>
+              <a:t>Sponsorship for Best Innovation &amp; Science pitch, or Poster winner prizes</a:t>
+            </a:r>
+            <a:endParaRPr lang="en-US" sz="1440" dirty="0"/>
+          </a:p>
+          <a:p>
             <a:pPr indent="0" marL="0">
               <a:buNone/>
             </a:pPr>
             <a:r>
-              <a:rPr lang="en-US" sz="5472" b="1" dirty="0">
-                <a:solidFill>
-                  <a:srgbClr val="8CCBF2"/>
-                </a:solidFill>
-                <a:latin typeface="Eurostile" pitchFamily="34" charset="0"/>
-                <a:ea typeface="Eurostile" pitchFamily="34" charset="-122"/>
-                <a:cs typeface="Eurostile" pitchFamily="34" charset="-120"/>
-              </a:rPr>
-              <a:t>#OILS26</a:t>
-            </a:r>
-            <a:endParaRPr lang="en-US" sz="5472" dirty="0"/>
-          </a:p>
-        </p:txBody>
-      </p:sp>
-      <p:sp>
-        <p:nvSpPr>
-          <p:cNvPr id="6" name="Text 2"/>
-          <p:cNvSpPr/>
-          <p:nvPr/>
-        </p:nvSpPr>
-        <p:spPr>
-          <a:xfrm>
-            <a:off x="3218688" y="1188720"/>
-            <a:ext cx="8229600" cy="402336"/>
-          </a:xfrm>
-          <a:prstGeom prst="rect">
-            <a:avLst/>
-          </a:prstGeom>
-          <a:noFill/>
-          <a:ln/>
-        </p:spPr>
-        <p:txBody>
-          <a:bodyPr wrap="square" lIns="0" tIns="0" rIns="0" bIns="0" rtlCol="0" anchor="ctr"/>
-          <a:lstStyle/>
-          <a:p>
-            <a:pPr indent="0" marL="0">
-              <a:buNone/>
-            </a:pPr>
-            <a:r>
-              <a:rPr lang="en-US" sz="2160" dirty="0">
+              <a:rPr lang="en-US" sz="1656" dirty="0">
                 <a:solidFill>
                   <a:srgbClr val="C9D6EC"/>
                 </a:solidFill>
@@ -3238,22 +3074,22 @@
                 <a:ea typeface="Arial" pitchFamily="34" charset="-122"/>
                 <a:cs typeface="Arial" pitchFamily="34" charset="-120"/>
               </a:rPr>
-              <a:t>Additional offers</a:t>
-            </a:r>
-            <a:endParaRPr lang="en-US" sz="2160" dirty="0"/>
-          </a:p>
-        </p:txBody>
-      </p:sp>
-      <p:sp>
-        <p:nvSpPr>
-          <p:cNvPr id="7" name="Text 3"/>
-          <p:cNvSpPr/>
-          <p:nvPr/>
-        </p:nvSpPr>
-        <p:spPr>
-          <a:xfrm>
-            <a:off x="731520" y="9418320"/>
-            <a:ext cx="10972800" cy="274320"/>
+              <a:t>Cash prize or giveaway (e.g. iPad, camera, gift certificate, etc.)</a:t>
+            </a:r>
+            <a:endParaRPr lang="en-US" sz="1440" dirty="0"/>
+          </a:p>
+        </p:txBody>
+      </p:sp>
+      <p:sp>
+        <p:nvSpPr>
+          <p:cNvPr id="74" name="Text 70"/>
+          <p:cNvSpPr/>
+          <p:nvPr/>
+        </p:nvSpPr>
+        <p:spPr>
+          <a:xfrm>
+            <a:off x="12618720" y="8156448"/>
+            <a:ext cx="4206240" cy="1024128"/>
           </a:xfrm>
           <a:prstGeom prst="rect">
             <a:avLst/>
@@ -3265,11 +3101,11 @@
           <a:bodyPr wrap="square" lIns="0" tIns="0" rIns="0" bIns="0" rtlCol="0" anchor="ctr"/>
           <a:lstStyle/>
           <a:p>
-            <a:pPr indent="0" marL="0">
-              <a:buNone/>
-            </a:pPr>
-            <a:r>
-              <a:rPr lang="en-US" sz="1440" spc="200" kern="0" dirty="0">
+            <a:pPr algn="ctr" indent="0" marL="0">
+              <a:buNone/>
+            </a:pPr>
+            <a:r>
+              <a:rPr lang="en-US" sz="2448" b="1" dirty="0">
                 <a:solidFill>
                   <a:srgbClr val="8CCBF2"/>
                 </a:solidFill>
@@ -3277,150 +3113,9 @@
                 <a:ea typeface="Arial" pitchFamily="34" charset="-122"/>
                 <a:cs typeface="Arial" pitchFamily="34" charset="-120"/>
               </a:rPr>
-              <a:t>OILS26  |  20 OCTOBER 2026  |  UNIVERSITY OF ZURICH</a:t>
-            </a:r>
-            <a:endParaRPr lang="en-US" sz="1440" dirty="0"/>
-          </a:p>
-        </p:txBody>
-      </p:sp>
-      <p:sp>
-        <p:nvSpPr>
-          <p:cNvPr id="8" name="Shape 4"/>
-          <p:cNvSpPr/>
-          <p:nvPr/>
-        </p:nvSpPr>
-        <p:spPr>
-          <a:xfrm>
-            <a:off x="731520" y="3657600"/>
-            <a:ext cx="16093440" cy="2743200"/>
-          </a:xfrm>
-          <a:prstGeom prst="roundRect">
-            <a:avLst>
-              <a:gd name="adj" fmla="val 4667"/>
-            </a:avLst>
-          </a:prstGeom>
-          <a:solidFill>
-            <a:srgbClr val="FFFFFF">
-              <a:alpha val="8000"/>
-            </a:srgbClr>
-          </a:solidFill>
-          <a:ln/>
-        </p:spPr>
-      </p:sp>
-      <p:sp>
-        <p:nvSpPr>
-          <p:cNvPr id="9" name="Shape 5"/>
-          <p:cNvSpPr/>
-          <p:nvPr/>
-        </p:nvSpPr>
-        <p:spPr>
-          <a:xfrm>
-            <a:off x="12435840" y="3657600"/>
-            <a:ext cx="4389120" cy="2743200"/>
-          </a:xfrm>
-          <a:prstGeom prst="rect">
-            <a:avLst/>
-          </a:prstGeom>
-          <a:solidFill>
-            <a:srgbClr val="8CCBF2">
-              <a:alpha val="20000"/>
-            </a:srgbClr>
-          </a:solidFill>
-          <a:ln/>
-        </p:spPr>
-      </p:sp>
-      <p:sp>
-        <p:nvSpPr>
-          <p:cNvPr id="10" name="Text 6"/>
-          <p:cNvSpPr/>
-          <p:nvPr/>
-        </p:nvSpPr>
-        <p:spPr>
-          <a:xfrm>
-            <a:off x="1042416" y="3657600"/>
-            <a:ext cx="11064240" cy="2743200"/>
-          </a:xfrm>
-          <a:prstGeom prst="rect">
-            <a:avLst/>
-          </a:prstGeom>
-          <a:noFill/>
-          <a:ln/>
-        </p:spPr>
-        <p:txBody>
-          <a:bodyPr wrap="square" lIns="0" tIns="0" rIns="0" bIns="0" rtlCol="0" anchor="ctr"/>
-          <a:lstStyle/>
-          <a:p>
-            <a:pPr indent="0" marL="0">
-              <a:buNone/>
-            </a:pPr>
-            <a:r>
-              <a:rPr lang="en-US" sz="3888" b="1" dirty="0">
-                <a:solidFill>
-                  <a:srgbClr val="FFFFFF"/>
-                </a:solidFill>
-                <a:latin typeface="Eurostile" pitchFamily="34" charset="0"/>
-                <a:ea typeface="Eurostile" pitchFamily="34" charset="-122"/>
-                <a:cs typeface="Eurostile" pitchFamily="34" charset="-120"/>
-              </a:rPr>
-              <a:t>Sponsorship for Best Innovation &amp; Science pitch, or Poster winner prizes</a:t>
-            </a:r>
-            <a:endParaRPr lang="en-US" sz="3888" dirty="0"/>
-          </a:p>
-          <a:p>
-            <a:pPr indent="0" marL="0">
-              <a:buNone/>
-            </a:pPr>
-            <a:r>
-              <a:rPr lang="en-US" sz="2448" dirty="0">
-                <a:solidFill>
-                  <a:srgbClr val="C9D6EC"/>
-                </a:solidFill>
-                <a:latin typeface="Arial" pitchFamily="34" charset="0"/>
-                <a:ea typeface="Arial" pitchFamily="34" charset="-122"/>
-                <a:cs typeface="Arial" pitchFamily="34" charset="-120"/>
-              </a:rPr>
-              <a:t>Cash prize or giveaway (e.g. iPad, camera, gift certificate, etc.)</a:t>
-            </a:r>
-            <a:endParaRPr lang="en-US" sz="3888" dirty="0"/>
-          </a:p>
-        </p:txBody>
-      </p:sp>
-      <p:sp>
-        <p:nvSpPr>
-          <p:cNvPr id="11" name="Text 7"/>
-          <p:cNvSpPr/>
-          <p:nvPr/>
-        </p:nvSpPr>
-        <p:spPr>
-          <a:xfrm>
-            <a:off x="12435840" y="3657600"/>
-            <a:ext cx="4389120" cy="2743200"/>
-          </a:xfrm>
-          <a:prstGeom prst="rect">
-            <a:avLst/>
-          </a:prstGeom>
-          <a:noFill/>
-          <a:ln/>
-        </p:spPr>
-        <p:txBody>
-          <a:bodyPr wrap="square" lIns="0" tIns="0" rIns="0" bIns="0" rtlCol="0" anchor="ctr"/>
-          <a:lstStyle/>
-          <a:p>
-            <a:pPr algn="ctr" indent="0" marL="0">
-              <a:buNone/>
-            </a:pPr>
-            <a:r>
-              <a:rPr lang="en-US" sz="3168" b="1" dirty="0">
-                <a:solidFill>
-                  <a:srgbClr val="8CCBF2"/>
-                </a:solidFill>
-                <a:latin typeface="Arial" pitchFamily="34" charset="0"/>
-                <a:ea typeface="Arial" pitchFamily="34" charset="-122"/>
-                <a:cs typeface="Arial" pitchFamily="34" charset="-120"/>
-              </a:rPr>
               <a:t>Open to discussion</a:t>
             </a:r>
-            <a:endParaRPr lang="en-US" sz="3168" dirty="0"/>
+            <a:endParaRPr lang="en-US" sz="2448" dirty="0"/>
           </a:p>
         </p:txBody>
       </p:sp>

</xml_diff>